<commit_message>
Reference Singapore salon and climate in training deck
Co-Authored-By: Claude Sonnet 5.5 <noreply@anthropic.com>
Claude-Session: https://claude.ai/code/session_01TSrk441tgkBcmTjqzDZ4p7
</commit_message>
<xml_diff>
--- a/XE-LHA-Peel-Staff-Training.pptx
+++ b/XE-LHA-Peel-Staff-Training.pptx
@@ -122,13 +122,13 @@
   <p:extLst>
     <p:ext uri="{521415D9-36F7-43E2-AB2F-B90AF26B5E84}">
       <p14:sectionLst xmlns:p14="http://schemas.microsoft.com/office/powerpoint/2010/main">
-        <p14:section name="Introduction 简介" id="{a64e8ec0-6a5c-9ed4-1a2e-26f3d2e4f4cb}">
+        <p14:section name="Introduction 简介" id="{9d2e1b59-94fd-a69a-d6a2-baeb1ee63426}">
           <p14:sldIdLst>
             <p14:sldId id="256"/>
             <p14:sldId id="257"/>
           </p14:sldIdLst>
         </p14:section>
-        <p14:section name="Product 产品" id="{ed305c95-f6a6-b071-5d78-e52089995f7c}">
+        <p14:section name="Product 产品" id="{377aa103-6c7d-6c7d-92fc-dd32ac0b3b6d}">
           <p14:sldIdLst>
             <p14:sldId id="258"/>
             <p14:sldId id="259"/>
@@ -136,21 +136,21 @@
             <p14:sldId id="261"/>
           </p14:sldIdLst>
         </p14:section>
-        <p14:section name="Procedure 操作流程" id="{57ec2797-440d-3fd5-6ad7-05d0815dcf69}">
+        <p14:section name="Procedure 操作流程" id="{40cecdc9-789f-8d3e-64b7-8cb3f966c96a}">
           <p14:sldIdLst>
             <p14:sldId id="262"/>
             <p14:sldId id="263"/>
             <p14:sldId id="264"/>
           </p14:sldIdLst>
         </p14:section>
-        <p14:section name="Safety 安全" id="{3ca879e4-a6aa-61ee-a355-0069577d283e}">
+        <p14:section name="Safety 安全" id="{48ef6fe2-5471-3e00-319a-fea7863be1ad}">
           <p14:sldIdLst>
             <p14:sldId id="265"/>
             <p14:sldId id="266"/>
             <p14:sldId id="267"/>
           </p14:sldIdLst>
         </p14:section>
-        <p14:section name="Reference 参考" id="{124f72c6-1329-30c4-1c14-db64dade3d3a}">
+        <p14:section name="Reference 参考" id="{028a72ea-e2a1-6b93-51c8-e829d12af0f0}">
           <p14:sldIdLst>
             <p14:sldId id="268"/>
             <p14:sldId id="269"/>
@@ -2842,7 +2842,7 @@
                   <a:srgbClr val="CFE0D2"/>
                 </a:solidFill>
               </a:rPr>
-              <a:t>门店 Salon: ______________________</a:t>
+              <a:t>门店 Salon: 新加坡 Singapore ‑ ______________</a:t>
             </a:r>
             <a:endParaRPr lang="en-US" sz="1400" dirty="0"/>
           </a:p>
@@ -4187,7 +4187,7 @@
                   <a:schemeClr val="bg1"/>
                 </a:solidFill>
               </a:rPr>
-              <a:t>7天核心守则：充分保湿 + 严格防晒！紫外线强，防晒重中之重</a:t>
+              <a:t>7天核心守则：充分保湿 + 严格防晒！新加坡紫外线强，防晒重中之重</a:t>
             </a:r>
             <a:endParaRPr lang="en-US" sz="1500" dirty="0"/>
           </a:p>
@@ -4204,7 +4204,7 @@
                   <a:srgbClr val="CFE0D2"/>
                 </a:solidFill>
               </a:rPr>
-              <a:t>Key rule for the first 7 days: heavy hydration + strict sun protection (strong UV in the tropics)</a:t>
+              <a:t>Key rule for the first 7 days: heavy hydration + strict sun protection (strong UV in Singapore)</a:t>
             </a:r>
             <a:endParaRPr lang="en-US" sz="1500" dirty="0"/>
           </a:p>
@@ -7402,7 +7402,7 @@
                   <a:srgbClr val="000000"/>
                 </a:solidFill>
               </a:rPr>
-              <a:t>规范操作几乎不会明显脱皮，少数人微微干燥紧绷，可以正常上班、化妆，几乎零恢复期，非常适合上班族。</a:t>
+              <a:t>规范操作几乎不会明显脱皮，少数人微微干燥紧绷，可以正常上班、化妆，几乎零恢复期，非常适合新加坡上班族。</a:t>
             </a:r>
             <a:endParaRPr lang="en-US" sz="1600" dirty="0"/>
           </a:p>
@@ -7419,7 +7419,7 @@
                   <a:schemeClr val="accent6"/>
                 </a:solidFill>
               </a:rPr>
-              <a:t>Proper treatment causes almost no visible peeling. Mild dryness or tightness is possible. Clients can work and wear makeup as normal — near‑zero downtime, perfect for busy working clients.</a:t>
+              <a:t>Proper treatment causes almost no visible peeling. Mild dryness or tightness is possible. Clients can work and wear makeup as normal — near‑zero downtime, perfect for busy Singapore working clients.</a:t>
             </a:r>
             <a:endParaRPr lang="en-US" sz="1600" dirty="0"/>
           </a:p>
@@ -10963,7 +10963,7 @@
                   <a:schemeClr val="accent6"/>
                 </a:solidFill>
               </a:rPr>
-              <a:t>Suits Asian skin &amp; climate</a:t>
+              <a:t>Suits Asian skin &amp; Singapore climate</a:t>
             </a:r>
             <a:endParaRPr lang="en-US" sz="1700" dirty="0"/>
           </a:p>
@@ -11002,7 +11002,7 @@
                   <a:schemeClr val="tx1"/>
                 </a:solidFill>
               </a:rPr>
-              <a:t>非常适合湿热气候，敏感肌经评估也可操作</a:t>
+              <a:t>非常适合新加坡湿热气候，敏感肌经评估也可操作</a:t>
             </a:r>
             <a:endParaRPr lang="en-US" sz="1400" dirty="0"/>
           </a:p>
@@ -11019,7 +11019,7 @@
                   <a:schemeClr val="accent6"/>
                 </a:solidFill>
               </a:rPr>
-              <a:t>Ideal for humid tropical weather; sensitive skin after skin assessment</a:t>
+              <a:t>Ideal for Singapore's humid tropical weather; sensitive skin after skin assessment</a:t>
             </a:r>
             <a:endParaRPr lang="en-US" sz="1400" dirty="0"/>
           </a:p>
@@ -13280,7 +13280,7 @@
                   <a:schemeClr val="tx1"/>
                 </a:solidFill>
               </a:rPr>
-              <a:t>改善毛孔粗大、黑头粉刺、油脂分泌旺盛（湿热出油肌首选）</a:t>
+              <a:t>改善毛孔粗大、黑头粉刺、油脂分泌旺盛（新加坡湿热出油肌首选）</a:t>
             </a:r>
             <a:endParaRPr lang="en-US" sz="1400" dirty="0"/>
           </a:p>
@@ -13297,7 +13297,7 @@
                   <a:schemeClr val="accent6"/>
                 </a:solidFill>
               </a:rPr>
-              <a:t>Minimises large pores, blackheads &amp; excess sebum — ideal for humid, oily skin</a:t>
+              <a:t>Minimises large pores, blackheads &amp; excess sebum — ideal for Singapore's humid, oily skin</a:t>
             </a:r>
             <a:endParaRPr lang="en-US" sz="1400" dirty="0"/>
           </a:p>
@@ -16472,7 +16472,7 @@
                   <a:schemeClr val="tx1"/>
                 </a:solidFill>
               </a:rPr>
-              <a:t>周操作1次（湿热肌建议2周）</a:t>
+              <a:t>周操作1次（新加坡湿热肌建议2周）</a:t>
             </a:r>
             <a:endParaRPr lang="en-US" sz="1400" dirty="0"/>
           </a:p>
@@ -16489,7 +16489,7 @@
                   <a:schemeClr val="accent6"/>
                 </a:solidFill>
               </a:rPr>
-              <a:t>weeks between sessions (2 weeks preferred for humid skin)</a:t>
+              <a:t>weeks between sessions (2 weeks preferred for Singapore humid skin)</a:t>
             </a:r>
             <a:endParaRPr lang="en-US" sz="1400" dirty="0"/>
           </a:p>

</xml_diff>